<commit_message>
AI Agent Registries - Copy.pptx: updated deck build
</commit_message>
<xml_diff>
--- a/nano-super-slides-v5/AI Agent Registries - Copy.pptx
+++ b/nano-super-slides-v5/AI Agent Registries - Copy.pptx
@@ -2134,8 +2134,7 @@
           <a:lstStyle/>
           <a:p>
             <a:r>
-              <a:rPr lang="en-US" dirty="0"/>
-              <a:t>Placeholder slide (user request, 2026-10-29): things we missed. Dummy text in dashed reserved boxes — to be filled in later.</a:t>
+              <a:t>Retitled 2026-10-29: Things Not Included in this presentation (was: Things we missed). Rows filled by the user; heading bitmap swapped in place via patch_s29_title.py.</a:t>
             </a:r>
           </a:p>
         </p:txBody>
@@ -31241,60 +31240,21 @@
           <p:nvPr/>
         </p:nvPicPr>
         <p:blipFill>
-          <a:blip r:embed="rId4"/>
+          <a:blip r:embed="rId5"/>
           <a:stretch>
             <a:fillRect/>
           </a:stretch>
         </p:blipFill>
         <p:spPr>
           <a:xfrm>
-            <a:off x="502920" y="658368"/>
-            <a:ext cx="6453051" cy="475488"/>
+            <a:off x="502920" y="640080"/>
+            <a:ext cx="8083296" cy="1052866"/>
           </a:xfrm>
           <a:prstGeom prst="rect">
             <a:avLst/>
           </a:prstGeom>
         </p:spPr>
       </p:pic>
-      <p:sp>
-        <p:nvSpPr>
-          <p:cNvPr id="7" name="s27_spec"/>
-          <p:cNvSpPr/>
-          <p:nvPr/>
-        </p:nvSpPr>
-        <p:spPr>
-          <a:xfrm>
-            <a:off x="502920" y="1216152"/>
-            <a:ext cx="10469880" cy="237744"/>
-          </a:xfrm>
-          <a:prstGeom prst="rect">
-            <a:avLst/>
-          </a:prstGeom>
-          <a:noFill/>
-          <a:ln/>
-        </p:spPr>
-        <p:txBody>
-          <a:bodyPr wrap="square" lIns="0" tIns="0" rIns="0" bIns="0" rtlCol="0" anchor="t"/>
-          <a:lstStyle/>
-          <a:p>
-            <a:pPr marL="0" indent="0" algn="l">
-              <a:buNone/>
-            </a:pPr>
-            <a:r>
-              <a:rPr lang="en-US" sz="1100" dirty="0">
-                <a:solidFill>
-                  <a:srgbClr val="5C6068"/>
-                </a:solidFill>
-                <a:latin typeface="Segoe UI" pitchFamily="34" charset="0"/>
-                <a:ea typeface="Segoe UI" pitchFamily="34" charset="-122"/>
-                <a:cs typeface="Segoe UI" pitchFamily="34" charset="-120"/>
-              </a:rPr>
-              <a:t>dummy rows below — replace with the real list before presenting</a:t>
-            </a:r>
-            <a:endParaRPr lang="en-US" sz="1100" dirty="0"/>
-          </a:p>
-        </p:txBody>
-      </p:sp>
       <p:sp>
         <p:nvSpPr>
           <p:cNvPr id="8" name="s27_pg"/>

</xml_diff>